<commit_message>
2025 update: multiple regression
</commit_message>
<xml_diff>
--- a/lecture-slides_upload/lab-activity/6-LinReg-output.pptx
+++ b/lecture-slides_upload/lab-activity/6-LinReg-output.pptx
@@ -274,7 +274,7 @@
           <a:p>
             <a:fld id="{9348304A-BD4A-884F-8142-E1638F7E50E4}" type="datetimeFigureOut">
               <a:rPr lang="en-US" smtClean="0"/>
-              <a:t>2/22/24</a:t>
+              <a:t>10/6/25</a:t>
             </a:fld>
             <a:endParaRPr lang="en-US"/>
           </a:p>
@@ -472,7 +472,7 @@
           <a:p>
             <a:fld id="{9348304A-BD4A-884F-8142-E1638F7E50E4}" type="datetimeFigureOut">
               <a:rPr lang="en-US" smtClean="0"/>
-              <a:t>2/22/24</a:t>
+              <a:t>10/6/25</a:t>
             </a:fld>
             <a:endParaRPr lang="en-US"/>
           </a:p>
@@ -680,7 +680,7 @@
           <a:p>
             <a:fld id="{9348304A-BD4A-884F-8142-E1638F7E50E4}" type="datetimeFigureOut">
               <a:rPr lang="en-US" smtClean="0"/>
-              <a:t>2/22/24</a:t>
+              <a:t>10/6/25</a:t>
             </a:fld>
             <a:endParaRPr lang="en-US"/>
           </a:p>
@@ -878,7 +878,7 @@
           <a:p>
             <a:fld id="{9348304A-BD4A-884F-8142-E1638F7E50E4}" type="datetimeFigureOut">
               <a:rPr lang="en-US" smtClean="0"/>
-              <a:t>2/22/24</a:t>
+              <a:t>10/6/25</a:t>
             </a:fld>
             <a:endParaRPr lang="en-US"/>
           </a:p>
@@ -1153,7 +1153,7 @@
           <a:p>
             <a:fld id="{9348304A-BD4A-884F-8142-E1638F7E50E4}" type="datetimeFigureOut">
               <a:rPr lang="en-US" smtClean="0"/>
-              <a:t>2/22/24</a:t>
+              <a:t>10/6/25</a:t>
             </a:fld>
             <a:endParaRPr lang="en-US"/>
           </a:p>
@@ -1418,7 +1418,7 @@
           <a:p>
             <a:fld id="{9348304A-BD4A-884F-8142-E1638F7E50E4}" type="datetimeFigureOut">
               <a:rPr lang="en-US" smtClean="0"/>
-              <a:t>2/22/24</a:t>
+              <a:t>10/6/25</a:t>
             </a:fld>
             <a:endParaRPr lang="en-US"/>
           </a:p>
@@ -1830,7 +1830,7 @@
           <a:p>
             <a:fld id="{9348304A-BD4A-884F-8142-E1638F7E50E4}" type="datetimeFigureOut">
               <a:rPr lang="en-US" smtClean="0"/>
-              <a:t>2/22/24</a:t>
+              <a:t>10/6/25</a:t>
             </a:fld>
             <a:endParaRPr lang="en-US"/>
           </a:p>
@@ -1971,7 +1971,7 @@
           <a:p>
             <a:fld id="{9348304A-BD4A-884F-8142-E1638F7E50E4}" type="datetimeFigureOut">
               <a:rPr lang="en-US" smtClean="0"/>
-              <a:t>2/22/24</a:t>
+              <a:t>10/6/25</a:t>
             </a:fld>
             <a:endParaRPr lang="en-US"/>
           </a:p>
@@ -2084,7 +2084,7 @@
           <a:p>
             <a:fld id="{9348304A-BD4A-884F-8142-E1638F7E50E4}" type="datetimeFigureOut">
               <a:rPr lang="en-US" smtClean="0"/>
-              <a:t>2/22/24</a:t>
+              <a:t>10/6/25</a:t>
             </a:fld>
             <a:endParaRPr lang="en-US"/>
           </a:p>
@@ -2395,7 +2395,7 @@
           <a:p>
             <a:fld id="{9348304A-BD4A-884F-8142-E1638F7E50E4}" type="datetimeFigureOut">
               <a:rPr lang="en-US" smtClean="0"/>
-              <a:t>2/22/24</a:t>
+              <a:t>10/6/25</a:t>
             </a:fld>
             <a:endParaRPr lang="en-US"/>
           </a:p>
@@ -2683,7 +2683,7 @@
           <a:p>
             <a:fld id="{9348304A-BD4A-884F-8142-E1638F7E50E4}" type="datetimeFigureOut">
               <a:rPr lang="en-US" smtClean="0"/>
-              <a:t>2/22/24</a:t>
+              <a:t>10/6/25</a:t>
             </a:fld>
             <a:endParaRPr lang="en-US"/>
           </a:p>
@@ -2924,7 +2924,7 @@
           <a:p>
             <a:fld id="{9348304A-BD4A-884F-8142-E1638F7E50E4}" type="datetimeFigureOut">
               <a:rPr lang="en-US" smtClean="0"/>
-              <a:t>2/22/24</a:t>
+              <a:t>10/6/25</a:t>
             </a:fld>
             <a:endParaRPr lang="en-US"/>
           </a:p>
@@ -3419,13 +3419,8 @@
           <a:p>
             <a:r>
               <a:rPr lang="en-US" dirty="0"/>
-              <a:t>with contributions from Vanessa </a:t>
-            </a:r>
-            <a:r>
-              <a:rPr lang="en-US" dirty="0" err="1"/>
-              <a:t>Lobue</a:t>
-            </a:r>
-            <a:endParaRPr lang="en-US" dirty="0"/>
+              <a:t>with help from Vanessa Lobue</a:t>
+            </a:r>
           </a:p>
         </p:txBody>
       </p:sp>
@@ -5932,7 +5927,7 @@
         </p:blipFill>
         <p:spPr>
           <a:xfrm>
-            <a:off x="690034" y="1703915"/>
+            <a:off x="690034" y="2105700"/>
             <a:ext cx="4711700" cy="2823423"/>
           </a:xfrm>
           <a:prstGeom prst="rect">
@@ -6228,7 +6223,7 @@
         </p:blipFill>
         <p:spPr>
           <a:xfrm>
-            <a:off x="1709925" y="1850705"/>
+            <a:off x="1709925" y="2252490"/>
             <a:ext cx="8772150" cy="4633178"/>
           </a:xfrm>
           <a:prstGeom prst="rect">

</xml_diff>